<commit_message>
[SR] Trying to fix videodb stuff
</commit_message>
<xml_diff>
--- a/cache/pitch.pptx
+++ b/cache/pitch.pptx
@@ -506,7 +506,7 @@
           <a:lstStyle/>
           <a:p>
             <a:r>
-              <a:t>Lead with the hard truth: our competitive analysis returned empty because Dove's actual creative assets are opaque. This isn't a failure—it's the insight. Dove has engineered strategic secrecy.</a:t>
+              <a:t>Opening with the hard truth from the JSON analysis: the dataset contains only ad identifiers without required metadata for competitive deconstruction.</a:t>
             </a:r>
           </a:p>
         </p:txBody>
@@ -576,7 +576,7 @@
           <a:lstStyle/>
           <a:p>
             <a:r>
-              <a:t>Emphasize the danger: without knowing Dove's emotional triggers or visual patterns, any creative response is guesswork. We are spending media dollars against an invisible strategy.</a:t>
+              <a:t>Highlighting the business risk of creating counter-creative without knowing what we are countering.</a:t>
             </a:r>
           </a:p>
         </p:txBody>
@@ -646,7 +646,7 @@
           <a:lstStyle/>
           <a:p>
             <a:r>
-              <a:t>Pivot from competitive intelligence to competitive transparency. If Dove hides their creative strategy, Nivea exposes everything—turning their secrecy into our strategic weapon.</a:t>
+              <a:t>The necessary intermediate step before any creative work can begin.</a:t>
             </a:r>
           </a:p>
         </p:txBody>
@@ -716,7 +716,7 @@
           <a:lstStyle/>
           <a:p>
             <a:r>
-              <a:t>The creative recommendation: don't mimic Dove's unseen emotional storytelling. Instead, attack the category's opacity. Show lab results, not just feelings. Make transparency the new premium positioning.</a:t>
+              <a:t>The counter-creative recommendation is strategic patience: we cannot recommend creative angles until we analyze actual content. This prevents budget waste.</a:t>
             </a:r>
           </a:p>
         </p:txBody>
@@ -3738,7 +3738,7 @@
           <a:lstStyle/>
           <a:p>
             <a:r>
-              <a:t>The Opacity Advantage: Turning Intelligence Gaps into Market Leadership</a:t>
+              <a:t>Competitive Blind Spot: Intelligence Before Creative</a:t>
             </a:r>
           </a:p>
         </p:txBody>
@@ -3798,7 +3798,7 @@
           <a:lstStyle/>
           <a:p>
             <a:r>
-              <a:t>The Insight: Intelligence Blackout</a:t>
+              <a:t>The Insight: We Have IDs, Not Intelligence</a:t>
             </a:r>
           </a:p>
         </p:txBody>
@@ -3822,7 +3822,7 @@
               <a:defRPr sz="1800"/>
             </a:pPr>
             <a:r>
-              <a:t>Dove's creative strategy operates in strategic darkness</a:t>
+              <a:t>Dove ad IDs identified: 2 assets flagged in dataset</a:t>
             </a:r>
           </a:p>
           <a:p>
@@ -3830,7 +3830,7 @@
               <a:defRPr sz="1800"/>
             </a:pPr>
             <a:r>
-              <a:t>Ad IDs exist without accessible creative analysis</a:t>
+              <a:t>Zero tactical metadata: No hooks, arcs, or visual cues mapped</a:t>
             </a:r>
           </a:p>
           <a:p>
@@ -3838,23 +3838,7 @@
               <a:defRPr sz="1800"/>
             </a:pPr>
             <a:r>
-              <a:t>Zero visibility into hooks, arcs, or emotional triggers</a:t>
-            </a:r>
-          </a:p>
-          <a:p>
-            <a:pPr>
-              <a:defRPr sz="1800"/>
-            </a:pPr>
-            <a:r>
-              <a:t>Competitive blindspot prevents effective counter-positioning</a:t>
-            </a:r>
-          </a:p>
-          <a:p>
-            <a:pPr>
-              <a:defRPr sz="1800"/>
-            </a:pPr>
-            <a:r>
-              <a:t>Pattern recognition impossible without content assets</a:t>
+              <a:t>Analysis impossible without full creative assets and timestamps</a:t>
             </a:r>
           </a:p>
         </p:txBody>
@@ -3893,7 +3877,7 @@
           <a:lstStyle/>
           <a:p>
             <a:r>
-              <a:t>The Risk: Flying Blind</a:t>
+              <a:t>The Risk: Flying Blind Into Production</a:t>
             </a:r>
           </a:p>
         </p:txBody>
@@ -3917,7 +3901,7 @@
               <a:defRPr sz="1800"/>
             </a:pPr>
             <a:r>
-              <a:t>Cannot counter-position against invisible frameworks</a:t>
+              <a:t>Unmapped competitive landscape risks wasted media spend</a:t>
             </a:r>
           </a:p>
           <a:p>
@@ -3925,7 +3909,7 @@
               <a:defRPr sz="1800"/>
             </a:pPr>
             <a:r>
-              <a:t>Reactive marketing risks mimicking unseen tactics</a:t>
+              <a:t>No visibility into Dove's emotional beats or messaging cadence</a:t>
             </a:r>
           </a:p>
           <a:p>
@@ -3933,23 +3917,7 @@
               <a:defRPr sz="1800"/>
             </a:pPr>
             <a:r>
-              <a:t>Competitor controls narrative transparency</a:t>
-            </a:r>
-          </a:p>
-          <a:p>
-            <a:pPr>
-              <a:defRPr sz="1800"/>
-            </a:pPr>
-            <a:r>
-              <a:t>Nivea lacks data to optimize creative spend</a:t>
-            </a:r>
-          </a:p>
-          <a:p>
-            <a:pPr>
-              <a:defRPr sz="1800"/>
-            </a:pPr>
-            <a:r>
-              <a:t>Market share vulnerability without intelligence advantage</a:t>
+              <a:t>Danger of unintentional imitation or missed differentiation</a:t>
             </a:r>
           </a:p>
         </p:txBody>
@@ -3988,7 +3956,7 @@
           <a:lstStyle/>
           <a:p>
             <a:r>
-              <a:t>The Strategic Pivot</a:t>
+              <a:t>The Pivot: Procurement First</a:t>
             </a:r>
           </a:p>
         </p:txBody>
@@ -4012,7 +3980,7 @@
               <a:defRPr sz="1800"/>
             </a:pPr>
             <a:r>
-              <a:t>Stop chasing Dove's opaque playbook immediately</a:t>
+              <a:t>Immediate procurement of full video assets required</a:t>
             </a:r>
           </a:p>
           <a:p>
@@ -4020,7 +3988,7 @@
               <a:defRPr sz="1800"/>
             </a:pPr>
             <a:r>
-              <a:t>Invest in proprietary first-party creative analytics</a:t>
+              <a:t>Frame-by-frame temporal mapping of hooks and visual patterns</a:t>
             </a:r>
           </a:p>
           <a:p>
@@ -4028,23 +3996,7 @@
               <a:defRPr sz="1800"/>
             </a:pPr>
             <a:r>
-              <a:t>Build transparent, measurable Nivea content framework</a:t>
-            </a:r>
-          </a:p>
-          <a:p>
-            <a:pPr>
-              <a:defRPr sz="1800"/>
-            </a:pPr>
-            <a:r>
-              <a:t>Establish distinct territory competitors cannot replicate</a:t>
-            </a:r>
-          </a:p>
-          <a:p>
-            <a:pPr>
-              <a:defRPr sz="1800"/>
-            </a:pPr>
-            <a:r>
-              <a:t>Force market to respond to Nivea's visibility</a:t>
+              <a:t>Only then can exploitable positioning gaps emerge</a:t>
             </a:r>
           </a:p>
         </p:txBody>
@@ -4083,7 +4035,7 @@
           <a:lstStyle/>
           <a:p>
             <a:r>
-              <a:t>Counter-Creative: Radical Transparency</a:t>
+              <a:t>Counter-Creative Recommendation: Pause &amp; Audit</a:t>
             </a:r>
           </a:p>
         </p:txBody>
@@ -4107,7 +4059,7 @@
               <a:defRPr sz="1800"/>
             </a:pPr>
             <a:r>
-              <a:t>Launch 'Proof Over Promises' campaign platform</a:t>
+              <a:t>Suspend Nivea creative production pending competitive intelligence</a:t>
             </a:r>
           </a:p>
           <a:p>
@@ -4115,7 +4067,7 @@
               <a:defRPr sz="1800"/>
             </a:pPr>
             <a:r>
-              <a:t>Expose real formulation science competitors conceal</a:t>
+              <a:t>Audit Dove's full creative archive with metadata extraction</a:t>
             </a:r>
           </a:p>
           <a:p>
@@ -4123,23 +4075,7 @@
               <a:defRPr sz="1800"/>
             </a:pPr>
             <a:r>
-              <a:t>Challenge category to publish verified efficacy data</a:t>
-            </a:r>
-          </a:p>
-          <a:p>
-            <a:pPr>
-              <a:defRPr sz="1800"/>
-            </a:pPr>
-            <a:r>
-              <a:t>Turn their secrecy into Nivea's credibility weapon</a:t>
-            </a:r>
-          </a:p>
-          <a:p>
-            <a:pPr>
-              <a:defRPr sz="1800"/>
-            </a:pPr>
-            <a:r>
-              <a:t>Own measurable skincare authority versus emotional ambiguity</a:t>
+              <a:t>Draft counter-creative only after verified gap analysis complete</a:t>
             </a:r>
           </a:p>
         </p:txBody>

</xml_diff>